<commit_message>
Refinements to SysMLv1 Layered Comms Profile, Example, Preso
</commit_message>
<xml_diff>
--- a/sysmlv1/doc/LayeredCommsProfileAndExampleSysMLv1.pptx
+++ b/sysmlv1/doc/LayeredCommsProfileAndExampleSysMLv1.pptx
@@ -227,7 +227,7 @@
           <a:p>
             <a:fld id="{098F015A-E505-BF46-94B6-972F77AA6CD4}" type="datetimeFigureOut">
               <a:rPr lang="en-US" smtClean="0"/>
-              <a:t>6/29/26</a:t>
+              <a:t>7/3/26</a:t>
             </a:fld>
             <a:endParaRPr lang="en-US"/>
           </a:p>
@@ -1293,10 +1293,9 @@
           <a:lstStyle/>
           <a:p>
             <a:r>
-              <a:rPr lang="en-US"/>
-              <a:t>CC-BY-4.0   27 June 2026</a:t>
-            </a:r>
-            <a:endParaRPr lang="en-US" dirty="0"/>
+              <a:rPr lang="en-US" dirty="0"/>
+              <a:t>CC-BY-4.0   03 July 2026</a:t>
+            </a:r>
           </a:p>
         </p:txBody>
       </p:sp>
@@ -1835,10 +1834,9 @@
           <a:lstStyle/>
           <a:p>
             <a:r>
-              <a:rPr lang="en-US"/>
-              <a:t>CC-BY-4.0   27 June 2026</a:t>
-            </a:r>
-            <a:endParaRPr lang="en-US" dirty="0"/>
+              <a:rPr lang="en-US" dirty="0"/>
+              <a:t>CC-BY-4.0   03 July 2026</a:t>
+            </a:r>
           </a:p>
         </p:txBody>
       </p:sp>
@@ -2536,10 +2534,9 @@
           <a:lstStyle/>
           <a:p>
             <a:r>
-              <a:rPr lang="en-US"/>
-              <a:t>CC-BY-4.0   27 June 2026</a:t>
-            </a:r>
-            <a:endParaRPr lang="en-US" dirty="0"/>
+              <a:rPr lang="en-US" dirty="0"/>
+              <a:t>CC-BY-4.0   03 July 2026</a:t>
+            </a:r>
           </a:p>
         </p:txBody>
       </p:sp>
@@ -3107,10 +3104,9 @@
           <a:lstStyle/>
           <a:p>
             <a:r>
-              <a:rPr lang="en-US"/>
-              <a:t>CC-BY-4.0   27 June 2026</a:t>
-            </a:r>
-            <a:endParaRPr lang="en-US" dirty="0"/>
+              <a:rPr lang="en-US" dirty="0"/>
+              <a:t>CC-BY-4.0   03 July 2026</a:t>
+            </a:r>
           </a:p>
         </p:txBody>
       </p:sp>
@@ -3678,10 +3674,9 @@
           <a:lstStyle/>
           <a:p>
             <a:r>
-              <a:rPr lang="en-US"/>
-              <a:t>CC-BY-4.0   27 June 2026</a:t>
-            </a:r>
-            <a:endParaRPr lang="en-US" dirty="0"/>
+              <a:rPr lang="en-US" dirty="0"/>
+              <a:t>CC-BY-4.0   03 July 2026</a:t>
+            </a:r>
           </a:p>
         </p:txBody>
       </p:sp>
@@ -4102,10 +4097,9 @@
           <a:lstStyle/>
           <a:p>
             <a:r>
-              <a:rPr lang="en-US"/>
-              <a:t>CC-BY-4.0   27 June 2026</a:t>
-            </a:r>
-            <a:endParaRPr lang="en-US" dirty="0"/>
+              <a:rPr lang="en-US" dirty="0"/>
+              <a:t>CC-BY-4.0   03 July 2026</a:t>
+            </a:r>
           </a:p>
         </p:txBody>
       </p:sp>
@@ -4526,10 +4520,9 @@
           <a:lstStyle/>
           <a:p>
             <a:r>
-              <a:rPr lang="en-US"/>
-              <a:t>CC-BY-4.0   27 June 2026</a:t>
-            </a:r>
-            <a:endParaRPr lang="en-US" dirty="0"/>
+              <a:rPr lang="en-US" dirty="0"/>
+              <a:t>CC-BY-4.0   03 July 2026</a:t>
+            </a:r>
           </a:p>
         </p:txBody>
       </p:sp>
@@ -5314,7 +5307,7 @@
             </a:pPr>
             <a:r>
               <a:rPr lang="en-US" dirty="0"/>
-              <a:t>CC-BY-4.0   27 June 2026</a:t>
+              <a:t>CC-BY-4.0   03 July 2026</a:t>
             </a:r>
           </a:p>
         </p:txBody>
@@ -5460,7 +5453,7 @@
             </a:pPr>
             <a:r>
               <a:rPr lang="en-US" dirty="0"/>
-              <a:t>CC-BY-4.0   27 June 2026</a:t>
+              <a:t>CC-BY-4.0   03 July 2026</a:t>
             </a:r>
           </a:p>
         </p:txBody>
@@ -7533,10 +7526,9 @@
           <a:lstStyle/>
           <a:p>
             <a:r>
-              <a:rPr lang="en-US"/>
-              <a:t>CC-BY-4.0   27 June 2026</a:t>
-            </a:r>
-            <a:endParaRPr lang="en-US" dirty="0"/>
+              <a:rPr lang="en-US" dirty="0"/>
+              <a:t>CC-BY-4.0   03 July 2026</a:t>
+            </a:r>
           </a:p>
         </p:txBody>
       </p:sp>
@@ -8029,10 +8021,9 @@
               <a:defRPr/>
             </a:pPr>
             <a:r>
-              <a:rPr lang="en-US"/>
-              <a:t>CC-BY-4.0 27 June 2026</a:t>
-            </a:r>
-            <a:endParaRPr lang="en-US" dirty="0"/>
+              <a:rPr lang="en-US" dirty="0"/>
+              <a:t>CC-BY-4.0 03 July 2026</a:t>
+            </a:r>
           </a:p>
         </p:txBody>
       </p:sp>
@@ -8276,10 +8267,9 @@
               <a:defRPr/>
             </a:pPr>
             <a:r>
-              <a:rPr lang="en-US"/>
-              <a:t>CC-BY-4.0   27 June 2026</a:t>
-            </a:r>
-            <a:endParaRPr lang="en-US" dirty="0"/>
+              <a:rPr lang="en-US" dirty="0"/>
+              <a:t>CC-BY-4.0   03 July 2026</a:t>
+            </a:r>
           </a:p>
         </p:txBody>
       </p:sp>
@@ -8689,10 +8679,9 @@
               <a:defRPr/>
             </a:pPr>
             <a:r>
-              <a:rPr lang="en-US"/>
-              <a:t>CC-BY-4.0   27 June 2026</a:t>
-            </a:r>
-            <a:endParaRPr lang="en-US" dirty="0"/>
+              <a:rPr lang="en-US" dirty="0"/>
+              <a:t>CC-BY-4.0   03 July 2026</a:t>
+            </a:r>
           </a:p>
         </p:txBody>
       </p:sp>
@@ -9065,10 +9054,9 @@
               <a:defRPr/>
             </a:pPr>
             <a:r>
-              <a:rPr lang="en-US"/>
-              <a:t>CC-BY-4.0   27 June 2026</a:t>
-            </a:r>
-            <a:endParaRPr lang="en-US" dirty="0"/>
+              <a:rPr lang="en-US" dirty="0"/>
+              <a:t>CC-BY-4.0   03 July 2026</a:t>
+            </a:r>
           </a:p>
         </p:txBody>
       </p:sp>
@@ -9739,7 +9727,7 @@
             </a:pPr>
             <a:r>
               <a:rPr lang="en-US" dirty="0"/>
-              <a:t>CC-BY-4.0   27 June 2026</a:t>
+              <a:t>CC-BY-4.0   03 July 2026</a:t>
             </a:r>
           </a:p>
         </p:txBody>
@@ -10552,58 +10540,6 @@
         <p:spPr>
           <a:xfrm>
             <a:off x="7906512" y="2125282"/>
-            <a:ext cx="533400" cy="152400"/>
-          </a:xfrm>
-          <a:prstGeom prst="rect">
-            <a:avLst/>
-          </a:prstGeom>
-          <a:ln>
-            <a:prstDash val="solid"/>
-          </a:ln>
-        </p:spPr>
-        <p:style>
-          <a:lnRef idx="2">
-            <a:schemeClr val="accent4">
-              <a:shade val="15000"/>
-            </a:schemeClr>
-          </a:lnRef>
-          <a:fillRef idx="1">
-            <a:schemeClr val="accent4"/>
-          </a:fillRef>
-          <a:effectRef idx="0">
-            <a:schemeClr val="accent4"/>
-          </a:effectRef>
-          <a:fontRef idx="minor">
-            <a:schemeClr val="lt1"/>
-          </a:fontRef>
-        </p:style>
-        <p:txBody>
-          <a:bodyPr rtlCol="0" anchor="ctr"/>
-          <a:lstStyle/>
-          <a:p>
-            <a:pPr algn="ctr"/>
-            <a:r>
-              <a:rPr lang="en-US" sz="1400" dirty="0"/>
-              <a:t>SAP</a:t>
-            </a:r>
-          </a:p>
-        </p:txBody>
-      </p:sp>
-      <p:sp>
-        <p:nvSpPr>
-          <p:cNvPr id="24" name="Rectangle 23">
-            <a:extLst>
-              <a:ext uri="{FF2B5EF4-FFF2-40B4-BE49-F238E27FC236}">
-                <a16:creationId xmlns:a16="http://schemas.microsoft.com/office/drawing/2014/main" id="{D5E53BAD-051C-849B-AF88-DE58AA7B6CD4}"/>
-              </a:ext>
-            </a:extLst>
-          </p:cNvPr>
-          <p:cNvSpPr/>
-          <p:nvPr/>
-        </p:nvSpPr>
-        <p:spPr>
-          <a:xfrm>
-            <a:off x="7888224" y="-414272"/>
             <a:ext cx="533400" cy="152400"/>
           </a:xfrm>
           <a:prstGeom prst="rect">
@@ -12272,7 +12208,7 @@
             </a:pPr>
             <a:r>
               <a:rPr lang="en-US" dirty="0"/>
-              <a:t>CC-BY-4.0   27 June 2026</a:t>
+              <a:t>CC-BY-4.0   03 July 2026</a:t>
             </a:r>
           </a:p>
         </p:txBody>
@@ -12477,7 +12413,7 @@
           <a:p>
             <a:r>
               <a:rPr lang="en-US" dirty="0"/>
-              <a:t>CC-BY-4.0   27 June 2026</a:t>
+              <a:t>CC-BY-4.0   03 July 2026</a:t>
             </a:r>
           </a:p>
         </p:txBody>
@@ -12673,7 +12609,7 @@
             </a:pPr>
             <a:r>
               <a:rPr lang="en-US" dirty="0"/>
-              <a:t>CC-BY-4.0   27 June 2026</a:t>
+              <a:t>CC-BY-4.0   03 July 2026</a:t>
             </a:r>
           </a:p>
         </p:txBody>
@@ -12827,7 +12763,7 @@
           <a:p>
             <a:r>
               <a:rPr lang="en-US" dirty="0"/>
-              <a:t>CC-BY-4.0   27 June 2026</a:t>
+              <a:t>CC-BY-4.0   03 July 2026</a:t>
             </a:r>
           </a:p>
         </p:txBody>
@@ -13073,7 +13009,7 @@
           <a:p>
             <a:r>
               <a:rPr lang="en-US" dirty="0"/>
-              <a:t>CC-BY-4.0   27 June 2026</a:t>
+              <a:t>CC-BY-4.0   03 July 2026</a:t>
             </a:r>
           </a:p>
         </p:txBody>
@@ -13316,7 +13252,7 @@
           <a:p>
             <a:r>
               <a:rPr lang="en-US" dirty="0"/>
-              <a:t>CC-BY-4.0   27 June 2026</a:t>
+              <a:t>CC-BY-4.0   03 July 2026</a:t>
             </a:r>
           </a:p>
         </p:txBody>
@@ -13519,7 +13455,7 @@
           <a:p>
             <a:r>
               <a:rPr lang="en-US" dirty="0"/>
-              <a:t>CC-BY-4.0   27 June 2026</a:t>
+              <a:t>CC-BY-4.0   03 July 2026</a:t>
             </a:r>
           </a:p>
         </p:txBody>
@@ -13720,7 +13656,7 @@
           <a:p>
             <a:r>
               <a:rPr lang="en-US" dirty="0"/>
-              <a:t>CC-BY-4.0   27 June 2026</a:t>
+              <a:t>CC-BY-4.0   03 July 2026</a:t>
             </a:r>
           </a:p>
         </p:txBody>
@@ -13922,7 +13858,7 @@
           <a:p>
             <a:r>
               <a:rPr lang="en-US" dirty="0"/>
-              <a:t>CC-BY-4.0   27 June 2026</a:t>
+              <a:t>CC-BY-4.0   03 July 2026</a:t>
             </a:r>
           </a:p>
         </p:txBody>
@@ -14041,7 +13977,7 @@
           <a:lstStyle/>
           <a:p>
             <a:r>
-              <a:rPr lang="en-US">
+              <a:rPr lang="en-US" dirty="0">
                 <a:latin typeface="Courier New" panose="02070309020205020404" pitchFamily="49" charset="0"/>
                 <a:cs typeface="Courier New" panose="02070309020205020404" pitchFamily="49" charset="0"/>
               </a:rPr>
@@ -14053,7 +13989,7 @@
               <a:buNone/>
             </a:pPr>
             <a:r>
-              <a:rPr lang="en-US">
+              <a:rPr lang="en-US" dirty="0">
                 <a:latin typeface="Courier New" panose="02070309020205020404" pitchFamily="49" charset="0"/>
                 <a:cs typeface="Courier New" panose="02070309020205020404" pitchFamily="49" charset="0"/>
               </a:rPr>
@@ -14065,11 +14001,25 @@
               <a:buNone/>
             </a:pPr>
             <a:r>
-              <a:rPr lang="en-US">
+              <a:rPr lang="en-US" dirty="0">
                 <a:latin typeface="Courier New" panose="02070309020205020404" pitchFamily="49" charset="0"/>
                 <a:cs typeface="Courier New" panose="02070309020205020404" pitchFamily="49" charset="0"/>
               </a:rPr>
-              <a:t>SPDX-FileCopyrightText: Copyright 2026 Guy Meador</a:t>
+              <a:t>SPDX-</a:t>
+            </a:r>
+            <a:r>
+              <a:rPr lang="en-US" dirty="0" err="1">
+                <a:latin typeface="Courier New" panose="02070309020205020404" pitchFamily="49" charset="0"/>
+                <a:cs typeface="Courier New" panose="02070309020205020404" pitchFamily="49" charset="0"/>
+              </a:rPr>
+              <a:t>FileCopyrightText</a:t>
+            </a:r>
+            <a:r>
+              <a:rPr lang="en-US" dirty="0">
+                <a:latin typeface="Courier New" panose="02070309020205020404" pitchFamily="49" charset="0"/>
+                <a:cs typeface="Courier New" panose="02070309020205020404" pitchFamily="49" charset="0"/>
+              </a:rPr>
+              <a:t>: Copyright 2026 Guy Meador</a:t>
             </a:r>
           </a:p>
           <a:p>
@@ -14077,11 +14027,25 @@
               <a:buNone/>
             </a:pPr>
             <a:r>
-              <a:rPr lang="en-US">
+              <a:rPr lang="en-US" dirty="0">
                 <a:latin typeface="Courier New" panose="02070309020205020404" pitchFamily="49" charset="0"/>
                 <a:cs typeface="Courier New" panose="02070309020205020404" pitchFamily="49" charset="0"/>
               </a:rPr>
-              <a:t>SPDX-FileType: DOCUMENTATION</a:t>
+              <a:t>SPDX-</a:t>
+            </a:r>
+            <a:r>
+              <a:rPr lang="en-US" dirty="0" err="1">
+                <a:latin typeface="Courier New" panose="02070309020205020404" pitchFamily="49" charset="0"/>
+                <a:cs typeface="Courier New" panose="02070309020205020404" pitchFamily="49" charset="0"/>
+              </a:rPr>
+              <a:t>FileType</a:t>
+            </a:r>
+            <a:r>
+              <a:rPr lang="en-US" dirty="0">
+                <a:latin typeface="Courier New" panose="02070309020205020404" pitchFamily="49" charset="0"/>
+                <a:cs typeface="Courier New" panose="02070309020205020404" pitchFamily="49" charset="0"/>
+              </a:rPr>
+              <a:t>: DOCUMENTATION</a:t>
             </a:r>
           </a:p>
           <a:p>
@@ -14089,11 +14053,25 @@
               <a:buNone/>
             </a:pPr>
             <a:r>
-              <a:rPr lang="en-US">
+              <a:rPr lang="en-US" dirty="0">
                 <a:latin typeface="Courier New" panose="02070309020205020404" pitchFamily="49" charset="0"/>
                 <a:cs typeface="Courier New" panose="02070309020205020404" pitchFamily="49" charset="0"/>
               </a:rPr>
-              <a:t>The MeadorTech logo(s) are trademarks of Meador Technologies, LLC, are used by special permission, and are not licensed as a part of this document or the licenses identified on this page. Derivative works are not authorized or licensed to use these logos.  </a:t>
+              <a:t>The </a:t>
+            </a:r>
+            <a:r>
+              <a:rPr lang="en-US" dirty="0" err="1">
+                <a:latin typeface="Courier New" panose="02070309020205020404" pitchFamily="49" charset="0"/>
+                <a:cs typeface="Courier New" panose="02070309020205020404" pitchFamily="49" charset="0"/>
+              </a:rPr>
+              <a:t>MeadorTech</a:t>
+            </a:r>
+            <a:r>
+              <a:rPr lang="en-US" dirty="0">
+                <a:latin typeface="Courier New" panose="02070309020205020404" pitchFamily="49" charset="0"/>
+                <a:cs typeface="Courier New" panose="02070309020205020404" pitchFamily="49" charset="0"/>
+              </a:rPr>
+              <a:t> logo(s) are trademarks of Meador Technologies, LLC, are used by special permission, and are not licensed as a part of this document or the licenses identified on this page. Derivative works are not authorized or licensed to use these logos.  </a:t>
             </a:r>
           </a:p>
           <a:p>
@@ -14101,7 +14079,7 @@
               <a:buNone/>
             </a:pPr>
             <a:r>
-              <a:rPr lang="en-US">
+              <a:rPr lang="en-US" dirty="0">
                 <a:latin typeface="Courier New" panose="02070309020205020404" pitchFamily="49" charset="0"/>
                 <a:cs typeface="Courier New" panose="02070309020205020404" pitchFamily="49" charset="0"/>
               </a:rPr>
@@ -14112,14 +14090,14 @@
             <a:pPr marL="0" indent="0">
               <a:buNone/>
             </a:pPr>
-            <a:endParaRPr lang="en-US">
+            <a:endParaRPr lang="en-US" dirty="0">
               <a:latin typeface="Courier New" panose="02070309020205020404" pitchFamily="49" charset="0"/>
               <a:cs typeface="Courier New" panose="02070309020205020404" pitchFamily="49" charset="0"/>
             </a:endParaRPr>
           </a:p>
           <a:p>
             <a:r>
-              <a:rPr lang="en-US">
+              <a:rPr lang="en-US" dirty="0">
                 <a:latin typeface="Courier New" panose="02070309020205020404" pitchFamily="49" charset="0"/>
                 <a:cs typeface="Courier New" panose="02070309020205020404" pitchFamily="49" charset="0"/>
               </a:rPr>
@@ -14131,7 +14109,7 @@
               <a:buNone/>
             </a:pPr>
             <a:r>
-              <a:rPr lang="en-US">
+              <a:rPr lang="en-US" dirty="0">
                 <a:latin typeface="Courier New" panose="02070309020205020404" pitchFamily="49" charset="0"/>
                 <a:cs typeface="Courier New" panose="02070309020205020404" pitchFamily="49" charset="0"/>
               </a:rPr>
@@ -14143,11 +14121,25 @@
               <a:buNone/>
             </a:pPr>
             <a:r>
-              <a:rPr lang="en-US">
+              <a:rPr lang="en-US" dirty="0">
                 <a:latin typeface="Courier New" panose="02070309020205020404" pitchFamily="49" charset="0"/>
                 <a:cs typeface="Courier New" panose="02070309020205020404" pitchFamily="49" charset="0"/>
               </a:rPr>
-              <a:t>SPDX-FileCopyrightText: Copyright 2026 Guy Meador</a:t>
+              <a:t>SPDX-</a:t>
+            </a:r>
+            <a:r>
+              <a:rPr lang="en-US" dirty="0" err="1">
+                <a:latin typeface="Courier New" panose="02070309020205020404" pitchFamily="49" charset="0"/>
+                <a:cs typeface="Courier New" panose="02070309020205020404" pitchFamily="49" charset="0"/>
+              </a:rPr>
+              <a:t>FileCopyrightText</a:t>
+            </a:r>
+            <a:r>
+              <a:rPr lang="en-US" dirty="0">
+                <a:latin typeface="Courier New" panose="02070309020205020404" pitchFamily="49" charset="0"/>
+                <a:cs typeface="Courier New" panose="02070309020205020404" pitchFamily="49" charset="0"/>
+              </a:rPr>
+              <a:t>: Copyright 2026 Guy Meador</a:t>
             </a:r>
           </a:p>
           <a:p>
@@ -14155,11 +14147,25 @@
               <a:buNone/>
             </a:pPr>
             <a:r>
-              <a:rPr lang="en-US">
+              <a:rPr lang="en-US" dirty="0">
                 <a:latin typeface="Courier New" panose="02070309020205020404" pitchFamily="49" charset="0"/>
                 <a:cs typeface="Courier New" panose="02070309020205020404" pitchFamily="49" charset="0"/>
               </a:rPr>
-              <a:t>SPDX-FileType: SysML</a:t>
+              <a:t>SPDX-</a:t>
+            </a:r>
+            <a:r>
+              <a:rPr lang="en-US" dirty="0" err="1">
+                <a:latin typeface="Courier New" panose="02070309020205020404" pitchFamily="49" charset="0"/>
+                <a:cs typeface="Courier New" panose="02070309020205020404" pitchFamily="49" charset="0"/>
+              </a:rPr>
+              <a:t>FileType</a:t>
+            </a:r>
+            <a:r>
+              <a:rPr lang="en-US" dirty="0">
+                <a:latin typeface="Courier New" panose="02070309020205020404" pitchFamily="49" charset="0"/>
+                <a:cs typeface="Courier New" panose="02070309020205020404" pitchFamily="49" charset="0"/>
+              </a:rPr>
+              <a:t>: SysML</a:t>
             </a:r>
             <a:endParaRPr lang="en-US" dirty="0"/>
           </a:p>
@@ -14222,7 +14228,7 @@
             </a:pPr>
             <a:r>
               <a:rPr lang="en-US" dirty="0"/>
-              <a:t>CC-BY-4.0   27 June 2026</a:t>
+              <a:t>CC-BY-4.0   03 July 2026</a:t>
             </a:r>
           </a:p>
         </p:txBody>
@@ -14346,7 +14352,7 @@
           <a:p>
             <a:r>
               <a:rPr lang="en-US" dirty="0"/>
-              <a:t>CC-BY-4.0   27 June 2026</a:t>
+              <a:t>CC-BY-4.0   03 July 2026</a:t>
             </a:r>
           </a:p>
         </p:txBody>
@@ -14628,7 +14634,7 @@
             </a:pPr>
             <a:r>
               <a:rPr lang="en-US" dirty="0"/>
-              <a:t>CC-BY-4.0   27 June 2026</a:t>
+              <a:t>CC-BY-4.0   03 July 2026</a:t>
             </a:r>
           </a:p>
         </p:txBody>
@@ -14882,7 +14888,7 @@
           <a:p>
             <a:r>
               <a:rPr lang="en-US" dirty="0"/>
-              <a:t>CC-BY-4.0   27 June 2026</a:t>
+              <a:t>CC-BY-4.0   03 July 2026</a:t>
             </a:r>
           </a:p>
         </p:txBody>
@@ -15165,7 +15171,7 @@
           <a:p>
             <a:r>
               <a:rPr lang="en-US" dirty="0"/>
-              <a:t>CC-BY-4.0   27 June 2026</a:t>
+              <a:t>CC-BY-4.0   03 July 2026</a:t>
             </a:r>
           </a:p>
         </p:txBody>
@@ -15362,7 +15368,7 @@
           <a:p>
             <a:r>
               <a:rPr lang="en-US" dirty="0"/>
-              <a:t>CC-BY-4.0   27 June 2026</a:t>
+              <a:t>CC-BY-4.0   03 July 2026</a:t>
             </a:r>
           </a:p>
         </p:txBody>
@@ -15520,7 +15526,7 @@
           <a:p>
             <a:r>
               <a:rPr lang="en-US" dirty="0"/>
-              <a:t>CC-BY-4.0   27 June 2026</a:t>
+              <a:t>CC-BY-4.0   03 July 2026</a:t>
             </a:r>
           </a:p>
         </p:txBody>
@@ -15705,7 +15711,7 @@
             </a:pPr>
             <a:r>
               <a:rPr lang="en-US" dirty="0"/>
-              <a:t>CC-BY-4.0   27 June 2026</a:t>
+              <a:t>CC-BY-4.0   03 July 2026</a:t>
             </a:r>
           </a:p>
         </p:txBody>
@@ -15957,7 +15963,7 @@
             </a:pPr>
             <a:r>
               <a:rPr lang="en-US" dirty="0"/>
-              <a:t>CC-BY-4.0   27 June 2026</a:t>
+              <a:t>CC-BY-4.0   03 July 2026</a:t>
             </a:r>
           </a:p>
         </p:txBody>
@@ -18568,7 +18574,7 @@
             </a:pPr>
             <a:r>
               <a:rPr lang="en-US" dirty="0"/>
-              <a:t>CC-BY-4.0   27 June 2026</a:t>
+              <a:t>CC-BY-4.0   03 July 2026</a:t>
             </a:r>
           </a:p>
         </p:txBody>
@@ -18801,7 +18807,7 @@
             </a:pPr>
             <a:r>
               <a:rPr lang="en-US" dirty="0"/>
-              <a:t>CC-BY-4.0   27 June 2026</a:t>
+              <a:t>CC-BY-4.0   03 July 2026</a:t>
             </a:r>
           </a:p>
         </p:txBody>
@@ -19016,7 +19022,7 @@
             </a:pPr>
             <a:r>
               <a:rPr lang="en-US" dirty="0"/>
-              <a:t>CC-BY-4.0   27 June 2026</a:t>
+              <a:t>CC-BY-4.0   03 July 2026</a:t>
             </a:r>
           </a:p>
         </p:txBody>
@@ -19133,7 +19139,7 @@
           <a:p>
             <a:r>
               <a:rPr lang="en-US" dirty="0"/>
-              <a:t>CC-BY-4.0   27 June 2026</a:t>
+              <a:t>CC-BY-4.0   03 July 2026</a:t>
             </a:r>
           </a:p>
         </p:txBody>
@@ -19431,7 +19437,7 @@
           <a:p>
             <a:r>
               <a:rPr lang="en-US" dirty="0"/>
-              <a:t>CC-BY-4.0   27 June 2026</a:t>
+              <a:t>CC-BY-4.0   03 July 2026</a:t>
             </a:r>
           </a:p>
         </p:txBody>
@@ -20696,7 +20702,7 @@
           <a:p>
             <a:r>
               <a:rPr lang="en-US" dirty="0"/>
-              <a:t>CC-BY-4.0   27 June 2026</a:t>
+              <a:t>CC-BY-4.0   03 July 2026</a:t>
             </a:r>
           </a:p>
         </p:txBody>
@@ -22165,7 +22171,7 @@
           <a:p>
             <a:r>
               <a:rPr lang="en-US" dirty="0"/>
-              <a:t>CC-BY-4.0   27 June 2026</a:t>
+              <a:t>CC-BY-4.0   03 July 2026</a:t>
             </a:r>
           </a:p>
         </p:txBody>
@@ -22437,7 +22443,7 @@
             </a:pPr>
             <a:r>
               <a:rPr lang="en-US" dirty="0"/>
-              <a:t>CC-BY-4.0   27 June 2026</a:t>
+              <a:t>CC-BY-4.0   03 July 2026</a:t>
             </a:r>
           </a:p>
         </p:txBody>
@@ -23065,7 +23071,7 @@
             </a:pPr>
             <a:r>
               <a:rPr lang="en-US" dirty="0"/>
-              <a:t>CC-BY-4.0   27 June 2026</a:t>
+              <a:t>CC-BY-4.0   03 July 2026</a:t>
             </a:r>
           </a:p>
         </p:txBody>
@@ -23878,58 +23884,6 @@
         <p:spPr>
           <a:xfrm>
             <a:off x="7906512" y="2125282"/>
-            <a:ext cx="533400" cy="152400"/>
-          </a:xfrm>
-          <a:prstGeom prst="rect">
-            <a:avLst/>
-          </a:prstGeom>
-          <a:ln>
-            <a:prstDash val="solid"/>
-          </a:ln>
-        </p:spPr>
-        <p:style>
-          <a:lnRef idx="2">
-            <a:schemeClr val="accent4">
-              <a:shade val="15000"/>
-            </a:schemeClr>
-          </a:lnRef>
-          <a:fillRef idx="1">
-            <a:schemeClr val="accent4"/>
-          </a:fillRef>
-          <a:effectRef idx="0">
-            <a:schemeClr val="accent4"/>
-          </a:effectRef>
-          <a:fontRef idx="minor">
-            <a:schemeClr val="lt1"/>
-          </a:fontRef>
-        </p:style>
-        <p:txBody>
-          <a:bodyPr rtlCol="0" anchor="ctr"/>
-          <a:lstStyle/>
-          <a:p>
-            <a:pPr algn="ctr"/>
-            <a:r>
-              <a:rPr lang="en-US" sz="1400" dirty="0"/>
-              <a:t>SAP</a:t>
-            </a:r>
-          </a:p>
-        </p:txBody>
-      </p:sp>
-      <p:sp>
-        <p:nvSpPr>
-          <p:cNvPr id="24" name="Rectangle 23">
-            <a:extLst>
-              <a:ext uri="{FF2B5EF4-FFF2-40B4-BE49-F238E27FC236}">
-                <a16:creationId xmlns:a16="http://schemas.microsoft.com/office/drawing/2014/main" id="{0E087674-2AD0-0A12-C60B-7991DE9A5C59}"/>
-              </a:ext>
-            </a:extLst>
-          </p:cNvPr>
-          <p:cNvSpPr/>
-          <p:nvPr/>
-        </p:nvSpPr>
-        <p:spPr>
-          <a:xfrm>
-            <a:off x="7888224" y="-414272"/>
             <a:ext cx="533400" cy="152400"/>
           </a:xfrm>
           <a:prstGeom prst="rect">
@@ -24573,7 +24527,7 @@
             </a:pPr>
             <a:r>
               <a:rPr lang="en-US" dirty="0"/>
-              <a:t>CC-BY-4.0   27 June 2026</a:t>
+              <a:t>CC-BY-4.0   03 July 2026</a:t>
             </a:r>
           </a:p>
         </p:txBody>
@@ -25386,58 +25340,6 @@
         <p:spPr>
           <a:xfrm>
             <a:off x="7906512" y="2125282"/>
-            <a:ext cx="533400" cy="152400"/>
-          </a:xfrm>
-          <a:prstGeom prst="rect">
-            <a:avLst/>
-          </a:prstGeom>
-          <a:ln>
-            <a:prstDash val="solid"/>
-          </a:ln>
-        </p:spPr>
-        <p:style>
-          <a:lnRef idx="2">
-            <a:schemeClr val="accent4">
-              <a:shade val="15000"/>
-            </a:schemeClr>
-          </a:lnRef>
-          <a:fillRef idx="1">
-            <a:schemeClr val="accent4"/>
-          </a:fillRef>
-          <a:effectRef idx="0">
-            <a:schemeClr val="accent4"/>
-          </a:effectRef>
-          <a:fontRef idx="minor">
-            <a:schemeClr val="lt1"/>
-          </a:fontRef>
-        </p:style>
-        <p:txBody>
-          <a:bodyPr rtlCol="0" anchor="ctr"/>
-          <a:lstStyle/>
-          <a:p>
-            <a:pPr algn="ctr"/>
-            <a:r>
-              <a:rPr lang="en-US" sz="1400" dirty="0"/>
-              <a:t>SAP</a:t>
-            </a:r>
-          </a:p>
-        </p:txBody>
-      </p:sp>
-      <p:sp>
-        <p:nvSpPr>
-          <p:cNvPr id="24" name="Rectangle 23">
-            <a:extLst>
-              <a:ext uri="{FF2B5EF4-FFF2-40B4-BE49-F238E27FC236}">
-                <a16:creationId xmlns:a16="http://schemas.microsoft.com/office/drawing/2014/main" id="{136726C2-C77A-B7B3-8EC1-808291C0F3FF}"/>
-              </a:ext>
-            </a:extLst>
-          </p:cNvPr>
-          <p:cNvSpPr/>
-          <p:nvPr/>
-        </p:nvSpPr>
-        <p:spPr>
-          <a:xfrm>
-            <a:off x="7888224" y="-414272"/>
             <a:ext cx="533400" cy="152400"/>
           </a:xfrm>
           <a:prstGeom prst="rect">
@@ -26229,7 +26131,7 @@
             </a:pPr>
             <a:r>
               <a:rPr lang="en-US" dirty="0"/>
-              <a:t>CC-BY-4.0   27 June 2026</a:t>
+              <a:t>CC-BY-4.0   03 July 2026</a:t>
             </a:r>
           </a:p>
         </p:txBody>
@@ -27042,58 +26944,6 @@
         <p:spPr>
           <a:xfrm>
             <a:off x="7906512" y="2125282"/>
-            <a:ext cx="533400" cy="152400"/>
-          </a:xfrm>
-          <a:prstGeom prst="rect">
-            <a:avLst/>
-          </a:prstGeom>
-          <a:ln>
-            <a:prstDash val="solid"/>
-          </a:ln>
-        </p:spPr>
-        <p:style>
-          <a:lnRef idx="2">
-            <a:schemeClr val="accent4">
-              <a:shade val="15000"/>
-            </a:schemeClr>
-          </a:lnRef>
-          <a:fillRef idx="1">
-            <a:schemeClr val="accent4"/>
-          </a:fillRef>
-          <a:effectRef idx="0">
-            <a:schemeClr val="accent4"/>
-          </a:effectRef>
-          <a:fontRef idx="minor">
-            <a:schemeClr val="lt1"/>
-          </a:fontRef>
-        </p:style>
-        <p:txBody>
-          <a:bodyPr rtlCol="0" anchor="ctr"/>
-          <a:lstStyle/>
-          <a:p>
-            <a:pPr algn="ctr"/>
-            <a:r>
-              <a:rPr lang="en-US" sz="1400" dirty="0"/>
-              <a:t>SAP</a:t>
-            </a:r>
-          </a:p>
-        </p:txBody>
-      </p:sp>
-      <p:sp>
-        <p:nvSpPr>
-          <p:cNvPr id="24" name="Rectangle 23">
-            <a:extLst>
-              <a:ext uri="{FF2B5EF4-FFF2-40B4-BE49-F238E27FC236}">
-                <a16:creationId xmlns:a16="http://schemas.microsoft.com/office/drawing/2014/main" id="{2D4F1FAA-805C-7078-EAEF-D13E24139B9A}"/>
-              </a:ext>
-            </a:extLst>
-          </p:cNvPr>
-          <p:cNvSpPr/>
-          <p:nvPr/>
-        </p:nvSpPr>
-        <p:spPr>
-          <a:xfrm>
-            <a:off x="7888224" y="-414272"/>
             <a:ext cx="533400" cy="152400"/>
           </a:xfrm>
           <a:prstGeom prst="rect">
@@ -29026,6 +28876,15 @@
 </file>
 
 <file path=customXml/item2.xml><?xml version="1.0" encoding="utf-8"?>
+<?mso-contentType ?>
+<FormTemplates xmlns="http://schemas.microsoft.com/sharepoint/v3/contenttype/forms">
+  <Display>DocumentLibraryForm</Display>
+  <Edit>DocumentLibraryForm</Edit>
+  <New>DocumentLibraryForm</New>
+</FormTemplates>
+</file>
+
+<file path=customXml/item3.xml><?xml version="1.0" encoding="utf-8"?>
 <p:properties xmlns:p="http://schemas.microsoft.com/office/2006/metadata/properties" xmlns:xsi="http://www.w3.org/2001/XMLSchema-instance" xmlns:pc="http://schemas.microsoft.com/office/infopath/2007/PartnerControls">
   <documentManagement>
     <TaxCatchAll xmlns="2a85b5b4-6539-4735-a06d-6874d3ecdf27" xsi:nil="true"/>
@@ -29034,15 +28893,6 @@
     </lcf76f155ced4ddcb4097134ff3c332f>
   </documentManagement>
 </p:properties>
-</file>
-
-<file path=customXml/item3.xml><?xml version="1.0" encoding="utf-8"?>
-<?mso-contentType ?>
-<FormTemplates xmlns="http://schemas.microsoft.com/sharepoint/v3/contenttype/forms">
-  <Display>DocumentLibraryForm</Display>
-  <Edit>DocumentLibraryForm</Edit>
-  <New>DocumentLibraryForm</New>
-</FormTemplates>
 </file>
 
 <file path=customXml/itemProps1.xml><?xml version="1.0" encoding="utf-8"?>
@@ -29065,6 +28915,14 @@
 </file>
 
 <file path=customXml/itemProps2.xml><?xml version="1.0" encoding="utf-8"?>
+<ds:datastoreItem xmlns:ds="http://schemas.openxmlformats.org/officeDocument/2006/customXml" ds:itemID="{CA832F03-6857-49B3-9CFC-2BBBF65F8A2E}">
+  <ds:schemaRefs>
+    <ds:schemaRef ds:uri="http://schemas.microsoft.com/sharepoint/v3/contenttype/forms"/>
+  </ds:schemaRefs>
+</ds:datastoreItem>
+</file>
+
+<file path=customXml/itemProps3.xml><?xml version="1.0" encoding="utf-8"?>
 <ds:datastoreItem xmlns:ds="http://schemas.openxmlformats.org/officeDocument/2006/customXml" ds:itemID="{BC197EB0-16EA-4CD3-9A74-622ED50F126B}">
   <ds:schemaRefs>
     <ds:schemaRef ds:uri="http://schemas.microsoft.com/office/infopath/2007/PartnerControls"/>
@@ -29079,12 +28937,4 @@
     <ds:schemaRef ds:uri="http://purl.org/dc/dcmitype/"/>
   </ds:schemaRefs>
 </ds:datastoreItem>
-</file>
-
-<file path=customXml/itemProps3.xml><?xml version="1.0" encoding="utf-8"?>
-<ds:datastoreItem xmlns:ds="http://schemas.openxmlformats.org/officeDocument/2006/customXml" ds:itemID="{CA832F03-6857-49B3-9CFC-2BBBF65F8A2E}">
-  <ds:schemaRefs>
-    <ds:schemaRef ds:uri="http://schemas.microsoft.com/sharepoint/v3/contenttype/forms"/>
-  </ds:schemaRefs>
-</ds:datastoreItem>
 </file>
</xml_diff>

<commit_message>
Updated readme and preso for SysML 1 assets
</commit_message>
<xml_diff>
--- a/sysmlv1/doc/LayeredCommsProfileAndExampleSysMLv1.pptx
+++ b/sysmlv1/doc/LayeredCommsProfileAndExampleSysMLv1.pptx
@@ -227,7 +227,7 @@
           <a:p>
             <a:fld id="{098F015A-E505-BF46-94B6-972F77AA6CD4}" type="datetimeFigureOut">
               <a:rPr lang="en-US" smtClean="0"/>
-              <a:t>7/3/26</a:t>
+              <a:t>7/31/26</a:t>
             </a:fld>
             <a:endParaRPr lang="en-US"/>
           </a:p>
@@ -1294,7 +1294,7 @@
           <a:p>
             <a:r>
               <a:rPr lang="en-US" dirty="0"/>
-              <a:t>CC-BY-4.0   03 July 2026</a:t>
+              <a:t>CC-BY-4.0 31 July 2026</a:t>
             </a:r>
           </a:p>
         </p:txBody>
@@ -1835,7 +1835,7 @@
           <a:p>
             <a:r>
               <a:rPr lang="en-US" dirty="0"/>
-              <a:t>CC-BY-4.0   03 July 2026</a:t>
+              <a:t>CC-BY-4.0 31 July 2026</a:t>
             </a:r>
           </a:p>
         </p:txBody>
@@ -2535,7 +2535,7 @@
           <a:p>
             <a:r>
               <a:rPr lang="en-US" dirty="0"/>
-              <a:t>CC-BY-4.0   03 July 2026</a:t>
+              <a:t>CC-BY-4.0 31 July 2026</a:t>
             </a:r>
           </a:p>
         </p:txBody>
@@ -3105,7 +3105,7 @@
           <a:p>
             <a:r>
               <a:rPr lang="en-US" dirty="0"/>
-              <a:t>CC-BY-4.0   03 July 2026</a:t>
+              <a:t>CC-BY-4.0 31 July 2026</a:t>
             </a:r>
           </a:p>
         </p:txBody>
@@ -3675,7 +3675,7 @@
           <a:p>
             <a:r>
               <a:rPr lang="en-US" dirty="0"/>
-              <a:t>CC-BY-4.0   03 July 2026</a:t>
+              <a:t>CC-BY-4.0 31 July 2026</a:t>
             </a:r>
           </a:p>
         </p:txBody>
@@ -4098,7 +4098,7 @@
           <a:p>
             <a:r>
               <a:rPr lang="en-US" dirty="0"/>
-              <a:t>CC-BY-4.0   03 July 2026</a:t>
+              <a:t>CC-BY-4.0 31 July 2026</a:t>
             </a:r>
           </a:p>
         </p:txBody>
@@ -4521,7 +4521,7 @@
           <a:p>
             <a:r>
               <a:rPr lang="en-US" dirty="0"/>
-              <a:t>CC-BY-4.0   03 July 2026</a:t>
+              <a:t>CC-BY-4.0 31 July 2026</a:t>
             </a:r>
           </a:p>
         </p:txBody>
@@ -5307,7 +5307,7 @@
             </a:pPr>
             <a:r>
               <a:rPr lang="en-US" dirty="0"/>
-              <a:t>CC-BY-4.0   03 July 2026</a:t>
+              <a:t>CC-BY-4.0 31 July 2026</a:t>
             </a:r>
           </a:p>
         </p:txBody>
@@ -5453,7 +5453,7 @@
             </a:pPr>
             <a:r>
               <a:rPr lang="en-US" dirty="0"/>
-              <a:t>CC-BY-4.0   03 July 2026</a:t>
+              <a:t>CC-BY-4.0 31 July 2026</a:t>
             </a:r>
           </a:p>
         </p:txBody>
@@ -7527,7 +7527,7 @@
           <a:p>
             <a:r>
               <a:rPr lang="en-US" dirty="0"/>
-              <a:t>CC-BY-4.0   03 July 2026</a:t>
+              <a:t>CC-BY-4.0   31 July 2026</a:t>
             </a:r>
           </a:p>
         </p:txBody>
@@ -8022,7 +8022,7 @@
             </a:pPr>
             <a:r>
               <a:rPr lang="en-US" dirty="0"/>
-              <a:t>CC-BY-4.0 03 July 2026</a:t>
+              <a:t>CC-BY-4.0 31 July 2026</a:t>
             </a:r>
           </a:p>
         </p:txBody>
@@ -8268,7 +8268,7 @@
             </a:pPr>
             <a:r>
               <a:rPr lang="en-US" dirty="0"/>
-              <a:t>CC-BY-4.0   03 July 2026</a:t>
+              <a:t>CC-BY-4.0 31 July 2026</a:t>
             </a:r>
           </a:p>
         </p:txBody>
@@ -8680,7 +8680,7 @@
             </a:pPr>
             <a:r>
               <a:rPr lang="en-US" dirty="0"/>
-              <a:t>CC-BY-4.0   03 July 2026</a:t>
+              <a:t>CC-BY-4.0 31 July 2026</a:t>
             </a:r>
           </a:p>
         </p:txBody>
@@ -9055,7 +9055,7 @@
             </a:pPr>
             <a:r>
               <a:rPr lang="en-US" dirty="0"/>
-              <a:t>CC-BY-4.0   03 July 2026</a:t>
+              <a:t>CC-BY-4.0   31 July 2026</a:t>
             </a:r>
           </a:p>
         </p:txBody>
@@ -9727,7 +9727,7 @@
             </a:pPr>
             <a:r>
               <a:rPr lang="en-US" dirty="0"/>
-              <a:t>CC-BY-4.0   03 July 2026</a:t>
+              <a:t>CC-BY-4.0   31 July 2026</a:t>
             </a:r>
           </a:p>
         </p:txBody>
@@ -12208,7 +12208,7 @@
             </a:pPr>
             <a:r>
               <a:rPr lang="en-US" dirty="0"/>
-              <a:t>CC-BY-4.0   03 July 2026</a:t>
+              <a:t>CC-BY-4.0   31 July 2026</a:t>
             </a:r>
           </a:p>
         </p:txBody>
@@ -12413,7 +12413,7 @@
           <a:p>
             <a:r>
               <a:rPr lang="en-US" dirty="0"/>
-              <a:t>CC-BY-4.0   03 July 2026</a:t>
+              <a:t>CC-BY-4.0   31 July 2026</a:t>
             </a:r>
           </a:p>
         </p:txBody>
@@ -12609,7 +12609,7 @@
             </a:pPr>
             <a:r>
               <a:rPr lang="en-US" dirty="0"/>
-              <a:t>CC-BY-4.0   03 July 2026</a:t>
+              <a:t>CC-BY-4.0   31 July 2026</a:t>
             </a:r>
           </a:p>
         </p:txBody>
@@ -12763,7 +12763,7 @@
           <a:p>
             <a:r>
               <a:rPr lang="en-US" dirty="0"/>
-              <a:t>CC-BY-4.0   03 July 2026</a:t>
+              <a:t>CC-BY-4.0   31 July 2026</a:t>
             </a:r>
           </a:p>
         </p:txBody>
@@ -13009,7 +13009,7 @@
           <a:p>
             <a:r>
               <a:rPr lang="en-US" dirty="0"/>
-              <a:t>CC-BY-4.0   03 July 2026</a:t>
+              <a:t>CC-BY-4.0   31 July 2026</a:t>
             </a:r>
           </a:p>
         </p:txBody>
@@ -13252,7 +13252,7 @@
           <a:p>
             <a:r>
               <a:rPr lang="en-US" dirty="0"/>
-              <a:t>CC-BY-4.0   03 July 2026</a:t>
+              <a:t>CC-BY-4.0   31 July 2026</a:t>
             </a:r>
           </a:p>
         </p:txBody>
@@ -13455,7 +13455,7 @@
           <a:p>
             <a:r>
               <a:rPr lang="en-US" dirty="0"/>
-              <a:t>CC-BY-4.0   03 July 2026</a:t>
+              <a:t>CC-BY-4.0   31 July 2026</a:t>
             </a:r>
           </a:p>
         </p:txBody>
@@ -13656,7 +13656,7 @@
           <a:p>
             <a:r>
               <a:rPr lang="en-US" dirty="0"/>
-              <a:t>CC-BY-4.0   03 July 2026</a:t>
+              <a:t>CC-BY-4.0   31 July 2026</a:t>
             </a:r>
           </a:p>
         </p:txBody>
@@ -13858,7 +13858,7 @@
           <a:p>
             <a:r>
               <a:rPr lang="en-US" dirty="0"/>
-              <a:t>CC-BY-4.0   03 July 2026</a:t>
+              <a:t>CC-BY-4.0   31 July 2026</a:t>
             </a:r>
           </a:p>
         </p:txBody>
@@ -14228,7 +14228,7 @@
             </a:pPr>
             <a:r>
               <a:rPr lang="en-US" dirty="0"/>
-              <a:t>CC-BY-4.0   03 July 2026</a:t>
+              <a:t>CC-BY-4.0   31 July 2026</a:t>
             </a:r>
           </a:p>
         </p:txBody>
@@ -14352,7 +14352,7 @@
           <a:p>
             <a:r>
               <a:rPr lang="en-US" dirty="0"/>
-              <a:t>CC-BY-4.0   03 July 2026</a:t>
+              <a:t>CC-BY-4.0   31 July 2026</a:t>
             </a:r>
           </a:p>
         </p:txBody>
@@ -14634,7 +14634,7 @@
             </a:pPr>
             <a:r>
               <a:rPr lang="en-US" dirty="0"/>
-              <a:t>CC-BY-4.0   03 July 2026</a:t>
+              <a:t>CC-BY-4.0   31 July 2026</a:t>
             </a:r>
           </a:p>
         </p:txBody>
@@ -14888,7 +14888,7 @@
           <a:p>
             <a:r>
               <a:rPr lang="en-US" dirty="0"/>
-              <a:t>CC-BY-4.0   03 July 2026</a:t>
+              <a:t>CC-BY-4.0   31 July 2026</a:t>
             </a:r>
           </a:p>
         </p:txBody>
@@ -15171,7 +15171,7 @@
           <a:p>
             <a:r>
               <a:rPr lang="en-US" dirty="0"/>
-              <a:t>CC-BY-4.0   03 July 2026</a:t>
+              <a:t>CC-BY-4.0   31 July 2026</a:t>
             </a:r>
           </a:p>
         </p:txBody>
@@ -15368,7 +15368,7 @@
           <a:p>
             <a:r>
               <a:rPr lang="en-US" dirty="0"/>
-              <a:t>CC-BY-4.0   03 July 2026</a:t>
+              <a:t>CC-BY-4.0   31 July 2026</a:t>
             </a:r>
           </a:p>
         </p:txBody>
@@ -15526,7 +15526,7 @@
           <a:p>
             <a:r>
               <a:rPr lang="en-US" dirty="0"/>
-              <a:t>CC-BY-4.0   03 July 2026</a:t>
+              <a:t>CC-BY-4.0   31 July 2026</a:t>
             </a:r>
           </a:p>
         </p:txBody>
@@ -15711,7 +15711,7 @@
             </a:pPr>
             <a:r>
               <a:rPr lang="en-US" dirty="0"/>
-              <a:t>CC-BY-4.0   03 July 2026</a:t>
+              <a:t>CC-BY-4.0   31 July 2026</a:t>
             </a:r>
           </a:p>
         </p:txBody>
@@ -15963,7 +15963,7 @@
             </a:pPr>
             <a:r>
               <a:rPr lang="en-US" dirty="0"/>
-              <a:t>CC-BY-4.0   03 July 2026</a:t>
+              <a:t>CC-BY-4.0   31 July 2026</a:t>
             </a:r>
           </a:p>
         </p:txBody>
@@ -18574,7 +18574,7 @@
             </a:pPr>
             <a:r>
               <a:rPr lang="en-US" dirty="0"/>
-              <a:t>CC-BY-4.0   03 July 2026</a:t>
+              <a:t>CC-BY-4.0   31 July 2026</a:t>
             </a:r>
           </a:p>
         </p:txBody>
@@ -18807,7 +18807,7 @@
             </a:pPr>
             <a:r>
               <a:rPr lang="en-US" dirty="0"/>
-              <a:t>CC-BY-4.0   03 July 2026</a:t>
+              <a:t>CC-BY-4.0   31 July 2026</a:t>
             </a:r>
           </a:p>
         </p:txBody>
@@ -19022,7 +19022,7 @@
             </a:pPr>
             <a:r>
               <a:rPr lang="en-US" dirty="0"/>
-              <a:t>CC-BY-4.0   03 July 2026</a:t>
+              <a:t>CC-BY-4.0   31 July 2026</a:t>
             </a:r>
           </a:p>
         </p:txBody>
@@ -19139,7 +19139,7 @@
           <a:p>
             <a:r>
               <a:rPr lang="en-US" dirty="0"/>
-              <a:t>CC-BY-4.0   03 July 2026</a:t>
+              <a:t>CC-BY-4.0   31 July 2026</a:t>
             </a:r>
           </a:p>
         </p:txBody>
@@ -19258,7 +19258,7 @@
         </p:spPr>
         <p:txBody>
           <a:bodyPr>
-            <a:normAutofit fontScale="77500" lnSpcReduction="20000"/>
+            <a:normAutofit fontScale="70000" lnSpcReduction="20000"/>
           </a:bodyPr>
           <a:lstStyle/>
           <a:p>
@@ -19343,16 +19343,23 @@
             </a:r>
           </a:p>
           <a:p>
+            <a:pPr lvl="1"/>
+            <a:r>
+              <a:rPr lang="en-US" sz="1600" dirty="0"/>
+              <a:t>Also, thank you to to the Layered Interface pattern subgroup and Russell Peak for their review and encouragement for the SysML 1 work described in this presentation.</a:t>
+            </a:r>
+          </a:p>
+          <a:p>
             <a:r>
               <a:rPr lang="en-US" sz="2000" dirty="0"/>
-              <a:t>SysML v1 MDZIP to be available</a:t>
+              <a:t>SysML v1 MDZIP is available</a:t>
             </a:r>
           </a:p>
           <a:p>
             <a:pPr lvl="1"/>
             <a:r>
               <a:rPr lang="en-US" sz="1600" dirty="0"/>
-              <a:t>The profile and example provided in this presentation will also be available at the above link.</a:t>
+              <a:t>The profile and example provided in this presentation is available at the above link.</a:t>
             </a:r>
           </a:p>
           <a:p>
@@ -19437,7 +19444,7 @@
           <a:p>
             <a:r>
               <a:rPr lang="en-US" dirty="0"/>
-              <a:t>CC-BY-4.0   03 July 2026</a:t>
+              <a:t>CC-BY-4.0   31 July 2026</a:t>
             </a:r>
           </a:p>
         </p:txBody>
@@ -20702,7 +20709,7 @@
           <a:p>
             <a:r>
               <a:rPr lang="en-US" dirty="0"/>
-              <a:t>CC-BY-4.0   03 July 2026</a:t>
+              <a:t>CC-BY-4.0   31 July 2026</a:t>
             </a:r>
           </a:p>
         </p:txBody>
@@ -22171,7 +22178,7 @@
           <a:p>
             <a:r>
               <a:rPr lang="en-US" dirty="0"/>
-              <a:t>CC-BY-4.0   03 July 2026</a:t>
+              <a:t>CC-BY-4.0   31 July 2026</a:t>
             </a:r>
           </a:p>
         </p:txBody>
@@ -22443,7 +22450,7 @@
             </a:pPr>
             <a:r>
               <a:rPr lang="en-US" dirty="0"/>
-              <a:t>CC-BY-4.0   03 July 2026</a:t>
+              <a:t>CC-BY-4.0   31 July 2026</a:t>
             </a:r>
           </a:p>
         </p:txBody>
@@ -23071,7 +23078,7 @@
             </a:pPr>
             <a:r>
               <a:rPr lang="en-US" dirty="0"/>
-              <a:t>CC-BY-4.0   03 July 2026</a:t>
+              <a:t>CC-BY-4.0   31 July 2026</a:t>
             </a:r>
           </a:p>
         </p:txBody>
@@ -24527,7 +24534,7 @@
             </a:pPr>
             <a:r>
               <a:rPr lang="en-US" dirty="0"/>
-              <a:t>CC-BY-4.0   03 July 2026</a:t>
+              <a:t>CC-BY-4.0   31 July 2026</a:t>
             </a:r>
           </a:p>
         </p:txBody>
@@ -26131,7 +26138,7 @@
             </a:pPr>
             <a:r>
               <a:rPr lang="en-US" dirty="0"/>
-              <a:t>CC-BY-4.0   03 July 2026</a:t>
+              <a:t>CC-BY-4.0   31 July 2026</a:t>
             </a:r>
           </a:p>
         </p:txBody>
@@ -28687,6 +28694,15 @@
 </file>
 
 <file path=customXml/item1.xml><?xml version="1.0" encoding="utf-8"?>
+<?mso-contentType ?>
+<FormTemplates xmlns="http://schemas.microsoft.com/sharepoint/v3/contenttype/forms">
+  <Display>DocumentLibraryForm</Display>
+  <Edit>DocumentLibraryForm</Edit>
+  <New>DocumentLibraryForm</New>
+</FormTemplates>
+</file>
+
+<file path=customXml/item2.xml><?xml version="1.0" encoding="utf-8"?>
 <ct:contentTypeSchema xmlns:ct="http://schemas.microsoft.com/office/2006/metadata/contentType" xmlns:ma="http://schemas.microsoft.com/office/2006/metadata/properties/metaAttributes" ct:_="" ma:_="" ma:contentTypeName="Document" ma:contentTypeID="0x0101007C77678108885D4B8820395B6FF466A6" ma:contentTypeVersion="10" ma:contentTypeDescription="Create a new document." ma:contentTypeScope="" ma:versionID="a4b4576a2f014f74a2d8009d3aae3077">
   <xsd:schema xmlns:xsd="http://www.w3.org/2001/XMLSchema" xmlns:xs="http://www.w3.org/2001/XMLSchema" xmlns:p="http://schemas.microsoft.com/office/2006/metadata/properties" xmlns:ns2="fe7cdfc6-4f18-4eca-ad51-38ee86e28cd4" xmlns:ns3="2a85b5b4-6539-4735-a06d-6874d3ecdf27" targetNamespace="http://schemas.microsoft.com/office/2006/metadata/properties" ma:root="true" ma:fieldsID="8c6ecec957aa84593719ca1ebeba2812" ns2:_="" ns3:_="">
     <xsd:import namespace="fe7cdfc6-4f18-4eca-ad51-38ee86e28cd4"/>
@@ -28875,15 +28891,6 @@
 </ct:contentTypeSchema>
 </file>
 
-<file path=customXml/item2.xml><?xml version="1.0" encoding="utf-8"?>
-<?mso-contentType ?>
-<FormTemplates xmlns="http://schemas.microsoft.com/sharepoint/v3/contenttype/forms">
-  <Display>DocumentLibraryForm</Display>
-  <Edit>DocumentLibraryForm</Edit>
-  <New>DocumentLibraryForm</New>
-</FormTemplates>
-</file>
-
 <file path=customXml/item3.xml><?xml version="1.0" encoding="utf-8"?>
 <p:properties xmlns:p="http://schemas.microsoft.com/office/2006/metadata/properties" xmlns:xsi="http://www.w3.org/2001/XMLSchema-instance" xmlns:pc="http://schemas.microsoft.com/office/infopath/2007/PartnerControls">
   <documentManagement>
@@ -28896,6 +28903,14 @@
 </file>
 
 <file path=customXml/itemProps1.xml><?xml version="1.0" encoding="utf-8"?>
+<ds:datastoreItem xmlns:ds="http://schemas.openxmlformats.org/officeDocument/2006/customXml" ds:itemID="{CA832F03-6857-49B3-9CFC-2BBBF65F8A2E}">
+  <ds:schemaRefs>
+    <ds:schemaRef ds:uri="http://schemas.microsoft.com/sharepoint/v3/contenttype/forms"/>
+  </ds:schemaRefs>
+</ds:datastoreItem>
+</file>
+
+<file path=customXml/itemProps2.xml><?xml version="1.0" encoding="utf-8"?>
 <ds:datastoreItem xmlns:ds="http://schemas.openxmlformats.org/officeDocument/2006/customXml" ds:itemID="{1CF8F676-45E4-4E2B-8835-6043B4BBAE58}">
   <ds:schemaRefs>
     <ds:schemaRef ds:uri="http://schemas.microsoft.com/office/2006/metadata/contentType"/>
@@ -28910,14 +28925,6 @@
     <ds:schemaRef ds:uri="http://purl.org/dc/elements/1.1/"/>
     <ds:schemaRef ds:uri="http://purl.org/dc/terms/"/>
     <ds:schemaRef ds:uri="http://schemas.microsoft.com/internal/obd"/>
-  </ds:schemaRefs>
-</ds:datastoreItem>
-</file>
-
-<file path=customXml/itemProps2.xml><?xml version="1.0" encoding="utf-8"?>
-<ds:datastoreItem xmlns:ds="http://schemas.openxmlformats.org/officeDocument/2006/customXml" ds:itemID="{CA832F03-6857-49B3-9CFC-2BBBF65F8A2E}">
-  <ds:schemaRefs>
-    <ds:schemaRef ds:uri="http://schemas.microsoft.com/sharepoint/v3/contenttype/forms"/>
   </ds:schemaRefs>
 </ds:datastoreItem>
 </file>

</xml_diff>